<commit_message>
Refine community and FG visual outputs
</commit_message>
<xml_diff>
--- a/results/traits_fg/glmmtmb_stable_fg_interpretation/FG_candidate_selection_tradeoff.pptx
+++ b/results/traits_fg/glmmtmb_stable_fg_interpretation/FG_candidate_selection_tradeoff.pptx
@@ -2216,16 +2216,16 @@
       </p:grpSpPr>
       <p:grpSp xmlns:pic="http://schemas.openxmlformats.org/drawingml/2006/picture">
         <p:nvGrpSpPr>
-          <p:cNvPr id="2" name=""/>
+          <p:cNvPr id="2" name="Content Placeholder 2"/>
           <p:cNvGrpSpPr/>
           <p:nvPr/>
         </p:nvGrpSpPr>
         <p:grpSpPr>
-          <a:xfrm rot="0">
-            <a:off x="0" y="0"/>
-            <a:ext cx="9144000" cy="6858000"/>
-            <a:chOff x="0" y="0"/>
-            <a:chExt cx="9144000" cy="6858000"/>
+          <a:xfrm>
+            <a:off x="457200" y="1600200"/>
+            <a:ext cx="8229600" cy="4525963"/>
+            <a:chOff x="457200" y="1600200"/>
+            <a:chExt cx="8229600" cy="4525963"/>
           </a:xfrm>
         </p:grpSpPr>
         <p:sp>
@@ -2236,8 +2236,8 @@
           </p:nvSpPr>
           <p:spPr>
             <a:xfrm>
-              <a:off x="0" y="0"/>
-              <a:ext cx="9144000" cy="6858000"/>
+              <a:off x="457200" y="1600200"/>
+              <a:ext cx="8229600" cy="4525962"/>
             </a:xfrm>
             <a:prstGeom prst="rect">
               <a:avLst/>
@@ -2271,8 +2271,8 @@
           </p:nvSpPr>
           <p:spPr>
             <a:xfrm>
-              <a:off x="0" y="0"/>
-              <a:ext cx="9143999" cy="6858000"/>
+              <a:off x="457200" y="1600200"/>
+              <a:ext cx="8229600" cy="4525962"/>
             </a:xfrm>
             <a:prstGeom prst="rect">
               <a:avLst/>
@@ -2306,8 +2306,8 @@
           </p:nvSpPr>
           <p:spPr>
             <a:xfrm>
-              <a:off x="536334" y="568962"/>
-              <a:ext cx="6004287" cy="5812358"/>
+              <a:off x="1148528" y="2238751"/>
+              <a:ext cx="4713473" cy="3205128"/>
             </a:xfrm>
             <a:prstGeom prst="rect">
               <a:avLst/>
@@ -2332,7 +2332,7 @@
           </p:nvSpPr>
           <p:spPr>
             <a:xfrm>
-              <a:off x="5096793" y="1045129"/>
+              <a:off x="4711695" y="2387099"/>
               <a:ext cx="156990" cy="156990"/>
             </a:xfrm>
             <a:prstGeom prst="ellipse">
@@ -2367,7 +2367,7 @@
           </p:nvSpPr>
           <p:spPr>
             <a:xfrm>
-              <a:off x="5765675" y="732988"/>
+              <a:off x="5232120" y="2284266"/>
               <a:ext cx="200345" cy="200345"/>
             </a:xfrm>
             <a:prstGeom prst="ellipse">
@@ -2402,7 +2402,7 @@
           </p:nvSpPr>
           <p:spPr>
             <a:xfrm>
-              <a:off x="3248164" y="1685669"/>
+              <a:off x="3268937" y="2758980"/>
               <a:ext cx="78389" cy="78389"/>
             </a:xfrm>
             <a:prstGeom prst="ellipse">
@@ -2437,7 +2437,7 @@
           </p:nvSpPr>
           <p:spPr>
             <a:xfrm>
-              <a:off x="1638268" y="5080175"/>
+              <a:off x="1999712" y="4706831"/>
               <a:ext cx="128883" cy="128883"/>
             </a:xfrm>
             <a:prstGeom prst="ellipse">
@@ -2472,7 +2472,7 @@
           </p:nvSpPr>
           <p:spPr>
             <a:xfrm>
-              <a:off x="756961" y="5988845"/>
+              <a:off x="1310482" y="5245897"/>
               <a:ext cx="104589" cy="104589"/>
             </a:xfrm>
             <a:prstGeom prst="ellipse">
@@ -2507,7 +2507,7 @@
           </p:nvSpPr>
           <p:spPr>
             <a:xfrm>
-              <a:off x="3067838" y="1826952"/>
+              <a:off x="3120831" y="3017292"/>
               <a:ext cx="139300" cy="139300"/>
             </a:xfrm>
             <a:prstGeom prst="ellipse">
@@ -2542,7 +2542,7 @@
           </p:nvSpPr>
           <p:spPr>
             <a:xfrm>
-              <a:off x="1984066" y="2579839"/>
+              <a:off x="2268836" y="3330622"/>
               <a:ext cx="150596" cy="150596"/>
             </a:xfrm>
             <a:prstGeom prst="ellipse">
@@ -2577,7 +2577,7 @@
           </p:nvSpPr>
           <p:spPr>
             <a:xfrm>
-              <a:off x="1023763" y="6057713"/>
+              <a:off x="1518396" y="5223756"/>
               <a:ext cx="118817" cy="118817"/>
             </a:xfrm>
             <a:prstGeom prst="ellipse">
@@ -2612,7 +2612,7 @@
           </p:nvSpPr>
           <p:spPr>
             <a:xfrm>
-              <a:off x="3368523" y="2453111"/>
+              <a:off x="3353704" y="3252684"/>
               <a:ext cx="168789" cy="168789"/>
             </a:xfrm>
             <a:prstGeom prst="ellipse">
@@ -2647,7 +2647,7 @@
           </p:nvSpPr>
           <p:spPr>
             <a:xfrm>
-              <a:off x="1163987" y="5362899"/>
+              <a:off x="1625407" y="4849417"/>
               <a:ext cx="147354" cy="147354"/>
             </a:xfrm>
             <a:prstGeom prst="ellipse">
@@ -2682,7 +2682,7 @@
           </p:nvSpPr>
           <p:spPr>
             <a:xfrm>
-              <a:off x="6173591" y="2336859"/>
+              <a:off x="5553645" y="3071362"/>
               <a:ext cx="188216" cy="188216"/>
             </a:xfrm>
             <a:prstGeom prst="ellipse">
@@ -2717,7 +2717,7 @@
           </p:nvSpPr>
           <p:spPr>
             <a:xfrm>
-              <a:off x="1558602" y="3904588"/>
+              <a:off x="1930225" y="4013943"/>
               <a:ext cx="193520" cy="193520"/>
             </a:xfrm>
             <a:prstGeom prst="ellipse">
@@ -2752,15 +2752,15 @@
           </p:nvSpPr>
           <p:spPr>
             <a:xfrm>
-              <a:off x="4711021" y="568962"/>
-              <a:ext cx="0" cy="5812358"/>
+              <a:off x="4425732" y="2238751"/>
+              <a:ext cx="0" cy="3205128"/>
             </a:xfrm>
             <a:custGeom>
               <a:avLst/>
               <a:pathLst>
-                <a:path w="0" h="5812358">
+                <a:path w="0" h="3205128">
                   <a:moveTo>
-                    <a:pt x="0" y="5812358"/>
+                    <a:pt x="0" y="3205128"/>
                   </a:moveTo>
                   <a:lnTo>
                     <a:pt x="0" y="0"/>
@@ -2795,21 +2795,21 @@
           </p:nvSpPr>
           <p:spPr>
             <a:xfrm>
-              <a:off x="536334" y="1861223"/>
-              <a:ext cx="6004287" cy="0"/>
+              <a:off x="1148528" y="2912281"/>
+              <a:ext cx="4713473" cy="0"/>
             </a:xfrm>
             <a:custGeom>
               <a:avLst/>
               <a:pathLst>
-                <a:path w="6004287" h="0">
+                <a:path w="4713473" h="0">
                   <a:moveTo>
                     <a:pt x="0" y="0"/>
                   </a:moveTo>
                   <a:lnTo>
-                    <a:pt x="6004287" y="0"/>
+                    <a:pt x="4713473" y="0"/>
                   </a:lnTo>
                   <a:lnTo>
-                    <a:pt x="6004287" y="0"/>
+                    <a:pt x="4713473" y="0"/>
                   </a:lnTo>
                 </a:path>
               </a:pathLst>
@@ -2832,13 +2832,53 @@
         </p:sp>
         <p:sp>
           <p:nvSpPr>
-            <p:cNvPr id="20" name="tx20"/>
-            <p:cNvSpPr/>
-            <p:nvPr/>
-          </p:nvSpPr>
-          <p:spPr>
-            <a:xfrm>
-              <a:off x="4918372" y="974697"/>
+            <p:cNvPr id="20" name="pl20"/>
+            <p:cNvSpPr/>
+            <p:nvPr/>
+          </p:nvSpPr>
+          <p:spPr>
+            <a:xfrm>
+              <a:off x="1593924" y="5202951"/>
+              <a:ext cx="246436" cy="75289"/>
+            </a:xfrm>
+            <a:custGeom>
+              <a:avLst/>
+              <a:pathLst>
+                <a:path w="246436" h="75289">
+                  <a:moveTo>
+                    <a:pt x="246436" y="0"/>
+                  </a:moveTo>
+                  <a:lnTo>
+                    <a:pt x="0" y="75289"/>
+                  </a:lnTo>
+                </a:path>
+              </a:pathLst>
+            </a:custGeom>
+            <a:ln w="13550" cap="rnd">
+              <a:solidFill>
+                <a:srgbClr val="999999">
+                  <a:alpha val="100000"/>
+                </a:srgbClr>
+              </a:solidFill>
+              <a:prstDash val="solid"/>
+              <a:round/>
+            </a:ln>
+          </p:spPr>
+          <p:txBody>
+            <a:bodyPr/>
+            <a:lstStyle/>
+            <a:p/>
+          </p:txBody>
+        </p:sp>
+        <p:sp>
+          <p:nvSpPr>
+            <p:cNvPr id="21" name="tx21"/>
+            <p:cNvSpPr/>
+            <p:nvPr/>
+          </p:nvSpPr>
+          <p:spPr>
+            <a:xfrm>
+              <a:off x="4280958" y="2519813"/>
               <a:ext cx="727442" cy="86441"/>
             </a:xfrm>
             <a:prstGeom prst="rect">
@@ -2878,13 +2918,13 @@
         </p:sp>
         <p:sp>
           <p:nvSpPr>
-            <p:cNvPr id="21" name="tx21"/>
-            <p:cNvSpPr/>
-            <p:nvPr/>
-          </p:nvSpPr>
-          <p:spPr>
-            <a:xfrm>
-              <a:off x="5607485" y="687383"/>
+            <p:cNvPr id="22" name="tx22"/>
+            <p:cNvSpPr/>
+            <p:nvPr/>
+          </p:nvSpPr>
+          <p:spPr>
+            <a:xfrm>
+              <a:off x="5088839" y="2280970"/>
               <a:ext cx="727442" cy="86441"/>
             </a:xfrm>
             <a:prstGeom prst="rect">
@@ -2924,13 +2964,13 @@
         </p:sp>
         <p:sp>
           <p:nvSpPr>
-            <p:cNvPr id="22" name="tx22"/>
-            <p:cNvSpPr/>
-            <p:nvPr/>
-          </p:nvSpPr>
-          <p:spPr>
-            <a:xfrm>
-              <a:off x="3041093" y="1577240"/>
+            <p:cNvPr id="23" name="tx23"/>
+            <p:cNvSpPr/>
+            <p:nvPr/>
+          </p:nvSpPr>
+          <p:spPr>
+            <a:xfrm>
+              <a:off x="2798394" y="2852877"/>
               <a:ext cx="727442" cy="86441"/>
             </a:xfrm>
             <a:prstGeom prst="rect">
@@ -2970,13 +3010,13 @@
         </p:sp>
         <p:sp>
           <p:nvSpPr>
-            <p:cNvPr id="23" name="tx23"/>
-            <p:cNvSpPr/>
-            <p:nvPr/>
-          </p:nvSpPr>
-          <p:spPr>
-            <a:xfrm>
-              <a:off x="1327092" y="5201787"/>
+            <p:cNvPr id="24" name="tx24"/>
+            <p:cNvSpPr/>
+            <p:nvPr/>
+          </p:nvSpPr>
+          <p:spPr>
+            <a:xfrm>
+              <a:off x="1939151" y="4627546"/>
               <a:ext cx="541008" cy="86159"/>
             </a:xfrm>
             <a:prstGeom prst="rect">
@@ -3016,13 +3056,13 @@
         </p:sp>
         <p:sp>
           <p:nvSpPr>
-            <p:cNvPr id="24" name="tx24"/>
-            <p:cNvSpPr/>
-            <p:nvPr/>
-          </p:nvSpPr>
-          <p:spPr>
-            <a:xfrm>
-              <a:off x="625858" y="5892441"/>
+            <p:cNvPr id="25" name="tx25"/>
+            <p:cNvSpPr/>
+            <p:nvPr/>
+          </p:nvSpPr>
+          <p:spPr>
+            <a:xfrm>
+              <a:off x="1194248" y="5311887"/>
               <a:ext cx="579515" cy="86272"/>
             </a:xfrm>
             <a:prstGeom prst="rect">
@@ -3062,13 +3102,13 @@
         </p:sp>
         <p:sp>
           <p:nvSpPr>
-            <p:cNvPr id="25" name="tx25"/>
-            <p:cNvSpPr/>
-            <p:nvPr/>
-          </p:nvSpPr>
-          <p:spPr>
-            <a:xfrm>
-              <a:off x="2875020" y="1754136"/>
+            <p:cNvPr id="26" name="tx26"/>
+            <p:cNvSpPr/>
+            <p:nvPr/>
+          </p:nvSpPr>
+          <p:spPr>
+            <a:xfrm>
+              <a:off x="2680728" y="3141123"/>
               <a:ext cx="727442" cy="86441"/>
             </a:xfrm>
             <a:prstGeom prst="rect">
@@ -3108,13 +3148,13 @@
         </p:sp>
         <p:sp>
           <p:nvSpPr>
-            <p:cNvPr id="26" name="tx26"/>
-            <p:cNvSpPr/>
-            <p:nvPr/>
-          </p:nvSpPr>
-          <p:spPr>
-            <a:xfrm>
-              <a:off x="1682659" y="2712962"/>
+            <p:cNvPr id="27" name="tx27"/>
+            <p:cNvSpPr/>
+            <p:nvPr/>
+          </p:nvSpPr>
+          <p:spPr>
+            <a:xfrm>
+              <a:off x="2220311" y="3261776"/>
               <a:ext cx="541008" cy="86159"/>
             </a:xfrm>
             <a:prstGeom prst="rect">
@@ -3154,13 +3194,13 @@
         </p:sp>
         <p:sp>
           <p:nvSpPr>
-            <p:cNvPr id="27" name="tx27"/>
-            <p:cNvSpPr/>
-            <p:nvPr/>
-          </p:nvSpPr>
-          <p:spPr>
-            <a:xfrm>
-              <a:off x="900495" y="6176036"/>
+            <p:cNvPr id="28" name="tx28"/>
+            <p:cNvSpPr/>
+            <p:nvPr/>
+          </p:nvSpPr>
+          <p:spPr>
+            <a:xfrm>
+              <a:off x="1863220" y="5152185"/>
               <a:ext cx="579515" cy="86272"/>
             </a:xfrm>
             <a:prstGeom prst="rect">
@@ -3200,13 +3240,13 @@
         </p:sp>
         <p:sp>
           <p:nvSpPr>
-            <p:cNvPr id="28" name="tx28"/>
-            <p:cNvSpPr/>
-            <p:nvPr/>
-          </p:nvSpPr>
-          <p:spPr>
-            <a:xfrm>
-              <a:off x="3076420" y="2593980"/>
+            <p:cNvPr id="29" name="tx29"/>
+            <p:cNvSpPr/>
+            <p:nvPr/>
+          </p:nvSpPr>
+          <p:spPr>
+            <a:xfrm>
+              <a:off x="3020943" y="3391671"/>
               <a:ext cx="541008" cy="86328"/>
             </a:xfrm>
             <a:prstGeom prst="rect">
@@ -3246,13 +3286,13 @@
         </p:sp>
         <p:sp>
           <p:nvSpPr>
-            <p:cNvPr id="29" name="tx29"/>
-            <p:cNvSpPr/>
-            <p:nvPr/>
-          </p:nvSpPr>
-          <p:spPr>
-            <a:xfrm>
-              <a:off x="843433" y="5493429"/>
+            <p:cNvPr id="30" name="tx30"/>
+            <p:cNvSpPr/>
+            <p:nvPr/>
+          </p:nvSpPr>
+          <p:spPr>
+            <a:xfrm>
+              <a:off x="1194623" y="4977766"/>
               <a:ext cx="579515" cy="86328"/>
             </a:xfrm>
             <a:prstGeom prst="rect">
@@ -3292,13 +3332,13 @@
         </p:sp>
         <p:sp>
           <p:nvSpPr>
-            <p:cNvPr id="30" name="tx30"/>
-            <p:cNvSpPr/>
-            <p:nvPr/>
-          </p:nvSpPr>
-          <p:spPr>
-            <a:xfrm>
-              <a:off x="5893759" y="2285337"/>
+            <p:cNvPr id="31" name="tx31"/>
+            <p:cNvSpPr/>
+            <p:nvPr/>
+          </p:nvSpPr>
+          <p:spPr>
+            <a:xfrm>
+              <a:off x="5106418" y="3021807"/>
               <a:ext cx="541008" cy="86159"/>
             </a:xfrm>
             <a:prstGeom prst="rect">
@@ -3338,13 +3378,13 @@
         </p:sp>
         <p:sp>
           <p:nvSpPr>
-            <p:cNvPr id="31" name="tx31"/>
-            <p:cNvSpPr/>
-            <p:nvPr/>
-          </p:nvSpPr>
-          <p:spPr>
-            <a:xfrm>
-              <a:off x="1472039" y="3854978"/>
+            <p:cNvPr id="32" name="tx32"/>
+            <p:cNvSpPr/>
+            <p:nvPr/>
+          </p:nvSpPr>
+          <p:spPr>
+            <a:xfrm>
+              <a:off x="1882194" y="3967018"/>
               <a:ext cx="579515" cy="86272"/>
             </a:xfrm>
             <a:prstGeom prst="rect">
@@ -3384,21 +3424,21 @@
         </p:sp>
         <p:sp>
           <p:nvSpPr>
-            <p:cNvPr id="32" name="pl32"/>
-            <p:cNvSpPr/>
-            <p:nvPr/>
-          </p:nvSpPr>
-          <p:spPr>
-            <a:xfrm>
-              <a:off x="536334" y="568962"/>
-              <a:ext cx="0" cy="5812358"/>
+            <p:cNvPr id="33" name="pl33"/>
+            <p:cNvSpPr/>
+            <p:nvPr/>
+          </p:nvSpPr>
+          <p:spPr>
+            <a:xfrm>
+              <a:off x="1148528" y="2238751"/>
+              <a:ext cx="0" cy="3205128"/>
             </a:xfrm>
             <a:custGeom>
               <a:avLst/>
               <a:pathLst>
-                <a:path w="0" h="5812358">
+                <a:path w="0" h="3205128">
                   <a:moveTo>
-                    <a:pt x="0" y="5812358"/>
+                    <a:pt x="0" y="3205128"/>
                   </a:moveTo>
                   <a:lnTo>
                     <a:pt x="0" y="0"/>
@@ -3424,13 +3464,13 @@
         </p:sp>
         <p:sp>
           <p:nvSpPr>
-            <p:cNvPr id="33" name="tx33"/>
-            <p:cNvSpPr/>
-            <p:nvPr/>
-          </p:nvSpPr>
-          <p:spPr>
-            <a:xfrm>
-              <a:off x="278707" y="5588788"/>
+            <p:cNvPr id="34" name="tx34"/>
+            <p:cNvSpPr/>
+            <p:nvPr/>
+          </p:nvSpPr>
+          <p:spPr>
+            <a:xfrm>
+              <a:off x="890901" y="4952765"/>
               <a:ext cx="183609" cy="94996"/>
             </a:xfrm>
             <a:prstGeom prst="rect">
@@ -3470,13 +3510,13 @@
         </p:sp>
         <p:sp>
           <p:nvSpPr>
-            <p:cNvPr id="34" name="tx34"/>
-            <p:cNvSpPr/>
-            <p:nvPr/>
-          </p:nvSpPr>
-          <p:spPr>
-            <a:xfrm>
-              <a:off x="278707" y="4078582"/>
+            <p:cNvPr id="35" name="tx35"/>
+            <p:cNvSpPr/>
+            <p:nvPr/>
+          </p:nvSpPr>
+          <p:spPr>
+            <a:xfrm>
+              <a:off x="890901" y="4117391"/>
               <a:ext cx="183609" cy="95125"/>
             </a:xfrm>
             <a:prstGeom prst="rect">
@@ -3516,13 +3556,13 @@
         </p:sp>
         <p:sp>
           <p:nvSpPr>
-            <p:cNvPr id="35" name="tx35"/>
-            <p:cNvSpPr/>
-            <p:nvPr/>
-          </p:nvSpPr>
-          <p:spPr>
-            <a:xfrm>
-              <a:off x="278707" y="2568763"/>
+            <p:cNvPr id="36" name="tx36"/>
+            <p:cNvSpPr/>
+            <p:nvPr/>
+          </p:nvSpPr>
+          <p:spPr>
+            <a:xfrm>
+              <a:off x="890901" y="3282405"/>
               <a:ext cx="183609" cy="94868"/>
             </a:xfrm>
             <a:prstGeom prst="rect">
@@ -3562,13 +3602,13 @@
         </p:sp>
         <p:sp>
           <p:nvSpPr>
-            <p:cNvPr id="36" name="tx36"/>
-            <p:cNvSpPr/>
-            <p:nvPr/>
-          </p:nvSpPr>
-          <p:spPr>
-            <a:xfrm>
-              <a:off x="278707" y="1058300"/>
+            <p:cNvPr id="37" name="tx37"/>
+            <p:cNvSpPr/>
+            <p:nvPr/>
+          </p:nvSpPr>
+          <p:spPr>
+            <a:xfrm>
+              <a:off x="890901" y="2446773"/>
               <a:ext cx="183609" cy="95254"/>
             </a:xfrm>
             <a:prstGeom prst="rect">
@@ -3608,13 +3648,13 @@
         </p:sp>
         <p:sp>
           <p:nvSpPr>
-            <p:cNvPr id="37" name="pl37"/>
-            <p:cNvSpPr/>
-            <p:nvPr/>
-          </p:nvSpPr>
-          <p:spPr>
-            <a:xfrm>
-              <a:off x="495213" y="5636415"/>
+            <p:cNvPr id="38" name="pl38"/>
+            <p:cNvSpPr/>
+            <p:nvPr/>
+          </p:nvSpPr>
+          <p:spPr>
+            <a:xfrm>
+              <a:off x="1107407" y="5000393"/>
               <a:ext cx="41120" cy="0"/>
             </a:xfrm>
             <a:custGeom>
@@ -3648,13 +3688,13 @@
         </p:sp>
         <p:sp>
           <p:nvSpPr>
-            <p:cNvPr id="38" name="pl38"/>
-            <p:cNvSpPr/>
-            <p:nvPr/>
-          </p:nvSpPr>
-          <p:spPr>
-            <a:xfrm>
-              <a:off x="495213" y="4126339"/>
+            <p:cNvPr id="39" name="pl39"/>
+            <p:cNvSpPr/>
+            <p:nvPr/>
+          </p:nvSpPr>
+          <p:spPr>
+            <a:xfrm>
+              <a:off x="1107407" y="4165148"/>
               <a:ext cx="41120" cy="0"/>
             </a:xfrm>
             <a:custGeom>
@@ -3688,13 +3728,13 @@
         </p:sp>
         <p:sp>
           <p:nvSpPr>
-            <p:cNvPr id="39" name="pl39"/>
-            <p:cNvSpPr/>
-            <p:nvPr/>
-          </p:nvSpPr>
-          <p:spPr>
-            <a:xfrm>
-              <a:off x="495213" y="2616262"/>
+            <p:cNvPr id="40" name="pl40"/>
+            <p:cNvSpPr/>
+            <p:nvPr/>
+          </p:nvSpPr>
+          <p:spPr>
+            <a:xfrm>
+              <a:off x="1107407" y="3329903"/>
               <a:ext cx="41120" cy="0"/>
             </a:xfrm>
             <a:custGeom>
@@ -3728,13 +3768,13 @@
         </p:sp>
         <p:sp>
           <p:nvSpPr>
-            <p:cNvPr id="40" name="pl40"/>
-            <p:cNvSpPr/>
-            <p:nvPr/>
-          </p:nvSpPr>
-          <p:spPr>
-            <a:xfrm>
-              <a:off x="495213" y="1106185"/>
+            <p:cNvPr id="41" name="pl41"/>
+            <p:cNvSpPr/>
+            <p:nvPr/>
+          </p:nvSpPr>
+          <p:spPr>
+            <a:xfrm>
+              <a:off x="1107407" y="2494658"/>
               <a:ext cx="41120" cy="0"/>
             </a:xfrm>
             <a:custGeom>
@@ -3768,24 +3808,24 @@
         </p:sp>
         <p:sp>
           <p:nvSpPr>
-            <p:cNvPr id="41" name="pl41"/>
-            <p:cNvSpPr/>
-            <p:nvPr/>
-          </p:nvSpPr>
-          <p:spPr>
-            <a:xfrm>
-              <a:off x="536334" y="6381320"/>
-              <a:ext cx="6004287" cy="0"/>
+            <p:cNvPr id="42" name="pl42"/>
+            <p:cNvSpPr/>
+            <p:nvPr/>
+          </p:nvSpPr>
+          <p:spPr>
+            <a:xfrm>
+              <a:off x="1148528" y="5443879"/>
+              <a:ext cx="4713473" cy="0"/>
             </a:xfrm>
             <a:custGeom>
               <a:avLst/>
               <a:pathLst>
-                <a:path w="6004287" h="0">
+                <a:path w="4713473" h="0">
                   <a:moveTo>
                     <a:pt x="0" y="0"/>
                   </a:moveTo>
                   <a:lnTo>
-                    <a:pt x="6004287" y="0"/>
+                    <a:pt x="4713473" y="0"/>
                   </a:lnTo>
                 </a:path>
               </a:pathLst>
@@ -3808,13 +3848,13 @@
         </p:sp>
         <p:sp>
           <p:nvSpPr>
-            <p:cNvPr id="42" name="pl42"/>
-            <p:cNvSpPr/>
-            <p:nvPr/>
-          </p:nvSpPr>
-          <p:spPr>
-            <a:xfrm>
-              <a:off x="951786" y="6381320"/>
+            <p:cNvPr id="43" name="pl43"/>
+            <p:cNvSpPr/>
+            <p:nvPr/>
+          </p:nvSpPr>
+          <p:spPr>
+            <a:xfrm>
+              <a:off x="1474665" y="5443879"/>
               <a:ext cx="0" cy="41120"/>
             </a:xfrm>
             <a:custGeom>
@@ -3848,13 +3888,13 @@
         </p:sp>
         <p:sp>
           <p:nvSpPr>
-            <p:cNvPr id="43" name="pl43"/>
-            <p:cNvSpPr/>
-            <p:nvPr/>
-          </p:nvSpPr>
-          <p:spPr>
-            <a:xfrm>
-              <a:off x="2057487" y="6381320"/>
+            <p:cNvPr id="44" name="pl44"/>
+            <p:cNvSpPr/>
+            <p:nvPr/>
+          </p:nvSpPr>
+          <p:spPr>
+            <a:xfrm>
+              <a:off x="2342661" y="5443879"/>
               <a:ext cx="0" cy="41120"/>
             </a:xfrm>
             <a:custGeom>
@@ -3888,13 +3928,13 @@
         </p:sp>
         <p:sp>
           <p:nvSpPr>
-            <p:cNvPr id="44" name="pl44"/>
-            <p:cNvSpPr/>
-            <p:nvPr/>
-          </p:nvSpPr>
-          <p:spPr>
-            <a:xfrm>
-              <a:off x="3163188" y="6381320"/>
+            <p:cNvPr id="45" name="pl45"/>
+            <p:cNvSpPr/>
+            <p:nvPr/>
+          </p:nvSpPr>
+          <p:spPr>
+            <a:xfrm>
+              <a:off x="3210656" y="5443879"/>
               <a:ext cx="0" cy="41120"/>
             </a:xfrm>
             <a:custGeom>
@@ -3928,13 +3968,13 @@
         </p:sp>
         <p:sp>
           <p:nvSpPr>
-            <p:cNvPr id="45" name="pl45"/>
-            <p:cNvSpPr/>
-            <p:nvPr/>
-          </p:nvSpPr>
-          <p:spPr>
-            <a:xfrm>
-              <a:off x="4268889" y="6381320"/>
+            <p:cNvPr id="46" name="pl46"/>
+            <p:cNvSpPr/>
+            <p:nvPr/>
+          </p:nvSpPr>
+          <p:spPr>
+            <a:xfrm>
+              <a:off x="4078651" y="5443879"/>
               <a:ext cx="0" cy="41120"/>
             </a:xfrm>
             <a:custGeom>
@@ -3968,13 +4008,13 @@
         </p:sp>
         <p:sp>
           <p:nvSpPr>
-            <p:cNvPr id="46" name="pl46"/>
-            <p:cNvSpPr/>
-            <p:nvPr/>
-          </p:nvSpPr>
-          <p:spPr>
-            <a:xfrm>
-              <a:off x="5374590" y="6381320"/>
+            <p:cNvPr id="47" name="pl47"/>
+            <p:cNvSpPr/>
+            <p:nvPr/>
+          </p:nvSpPr>
+          <p:spPr>
+            <a:xfrm>
+              <a:off x="4946646" y="5443879"/>
               <a:ext cx="0" cy="41120"/>
             </a:xfrm>
             <a:custGeom>
@@ -4008,13 +4048,13 @@
         </p:sp>
         <p:sp>
           <p:nvSpPr>
-            <p:cNvPr id="47" name="pl47"/>
-            <p:cNvSpPr/>
-            <p:nvPr/>
-          </p:nvSpPr>
-          <p:spPr>
-            <a:xfrm>
-              <a:off x="6480291" y="6381320"/>
+            <p:cNvPr id="48" name="pl48"/>
+            <p:cNvSpPr/>
+            <p:nvPr/>
+          </p:nvSpPr>
+          <p:spPr>
+            <a:xfrm>
+              <a:off x="5814642" y="5443879"/>
               <a:ext cx="0" cy="41120"/>
             </a:xfrm>
             <a:custGeom>
@@ -4048,13 +4088,13 @@
         </p:sp>
         <p:sp>
           <p:nvSpPr>
-            <p:cNvPr id="48" name="tx48"/>
-            <p:cNvSpPr/>
-            <p:nvPr/>
-          </p:nvSpPr>
-          <p:spPr>
-            <a:xfrm>
-              <a:off x="786525" y="6455209"/>
+            <p:cNvPr id="49" name="tx49"/>
+            <p:cNvSpPr/>
+            <p:nvPr/>
+          </p:nvSpPr>
+          <p:spPr>
+            <a:xfrm>
+              <a:off x="1309404" y="5517768"/>
               <a:ext cx="330522" cy="94868"/>
             </a:xfrm>
             <a:prstGeom prst="rect">
@@ -4094,13 +4134,13 @@
         </p:sp>
         <p:sp>
           <p:nvSpPr>
-            <p:cNvPr id="49" name="tx49"/>
-            <p:cNvSpPr/>
-            <p:nvPr/>
-          </p:nvSpPr>
-          <p:spPr>
-            <a:xfrm>
-              <a:off x="1892226" y="6455209"/>
+            <p:cNvPr id="50" name="tx50"/>
+            <p:cNvSpPr/>
+            <p:nvPr/>
+          </p:nvSpPr>
+          <p:spPr>
+            <a:xfrm>
+              <a:off x="2177399" y="5517768"/>
               <a:ext cx="330522" cy="94868"/>
             </a:xfrm>
             <a:prstGeom prst="rect">
@@ -4140,13 +4180,13 @@
         </p:sp>
         <p:sp>
           <p:nvSpPr>
-            <p:cNvPr id="50" name="tx50"/>
-            <p:cNvSpPr/>
-            <p:nvPr/>
-          </p:nvSpPr>
-          <p:spPr>
-            <a:xfrm>
-              <a:off x="2997927" y="6454886"/>
+            <p:cNvPr id="51" name="tx51"/>
+            <p:cNvSpPr/>
+            <p:nvPr/>
+          </p:nvSpPr>
+          <p:spPr>
+            <a:xfrm>
+              <a:off x="3045395" y="5517445"/>
               <a:ext cx="330522" cy="95190"/>
             </a:xfrm>
             <a:prstGeom prst="rect">
@@ -4186,13 +4226,13 @@
         </p:sp>
         <p:sp>
           <p:nvSpPr>
-            <p:cNvPr id="51" name="tx51"/>
-            <p:cNvSpPr/>
-            <p:nvPr/>
-          </p:nvSpPr>
-          <p:spPr>
-            <a:xfrm>
-              <a:off x="4103628" y="6454886"/>
+            <p:cNvPr id="52" name="tx52"/>
+            <p:cNvSpPr/>
+            <p:nvPr/>
+          </p:nvSpPr>
+          <p:spPr>
+            <a:xfrm>
+              <a:off x="3913390" y="5517445"/>
               <a:ext cx="330522" cy="95190"/>
             </a:xfrm>
             <a:prstGeom prst="rect">
@@ -4232,13 +4272,13 @@
         </p:sp>
         <p:sp>
           <p:nvSpPr>
-            <p:cNvPr id="52" name="tx52"/>
-            <p:cNvSpPr/>
-            <p:nvPr/>
-          </p:nvSpPr>
-          <p:spPr>
-            <a:xfrm>
-              <a:off x="5209329" y="6454886"/>
+            <p:cNvPr id="53" name="tx53"/>
+            <p:cNvSpPr/>
+            <p:nvPr/>
+          </p:nvSpPr>
+          <p:spPr>
+            <a:xfrm>
+              <a:off x="4781385" y="5517445"/>
               <a:ext cx="330522" cy="95190"/>
             </a:xfrm>
             <a:prstGeom prst="rect">
@@ -4278,13 +4318,13 @@
         </p:sp>
         <p:sp>
           <p:nvSpPr>
-            <p:cNvPr id="53" name="tx53"/>
-            <p:cNvSpPr/>
-            <p:nvPr/>
-          </p:nvSpPr>
-          <p:spPr>
-            <a:xfrm>
-              <a:off x="6315030" y="6454886"/>
+            <p:cNvPr id="54" name="tx54"/>
+            <p:cNvSpPr/>
+            <p:nvPr/>
+          </p:nvSpPr>
+          <p:spPr>
+            <a:xfrm>
+              <a:off x="5649380" y="5517445"/>
               <a:ext cx="330522" cy="95190"/>
             </a:xfrm>
             <a:prstGeom prst="rect">
@@ -4324,13 +4364,13 @@
         </p:sp>
         <p:sp>
           <p:nvSpPr>
-            <p:cNvPr id="54" name="tx54"/>
-            <p:cNvSpPr/>
-            <p:nvPr/>
-          </p:nvSpPr>
-          <p:spPr>
-            <a:xfrm>
-              <a:off x="2561461" y="6583732"/>
+            <p:cNvPr id="55" name="tx55"/>
+            <p:cNvSpPr/>
+            <p:nvPr/>
+          </p:nvSpPr>
+          <p:spPr>
+            <a:xfrm>
+              <a:off x="2528249" y="5706391"/>
               <a:ext cx="1954032" cy="155506"/>
             </a:xfrm>
             <a:prstGeom prst="rect">
@@ -4370,13 +4410,13 @@
         </p:sp>
         <p:sp>
           <p:nvSpPr>
-            <p:cNvPr id="55" name="tx55"/>
+            <p:cNvPr id="56" name="tx56"/>
             <p:cNvSpPr/>
             <p:nvPr/>
           </p:nvSpPr>
           <p:spPr>
             <a:xfrm rot="-5400000">
-              <a:off x="-1270522" y="3398073"/>
+              <a:off x="-718428" y="3764247"/>
               <a:ext cx="2789045" cy="154136"/>
             </a:xfrm>
             <a:prstGeom prst="rect">
@@ -4416,13 +4456,13 @@
         </p:sp>
         <p:sp>
           <p:nvSpPr>
-            <p:cNvPr id="56" name="rc56"/>
-            <p:cNvSpPr/>
-            <p:nvPr/>
-          </p:nvSpPr>
-          <p:spPr>
-            <a:xfrm>
-              <a:off x="6705105" y="2438803"/>
+            <p:cNvPr id="57" name="rc57"/>
+            <p:cNvSpPr/>
+            <p:nvPr/>
+          </p:nvSpPr>
+          <p:spPr>
+            <a:xfrm>
+              <a:off x="6026485" y="2804977"/>
               <a:ext cx="2356653" cy="1067211"/>
             </a:xfrm>
             <a:prstGeom prst="rect">
@@ -4442,13 +4482,13 @@
         </p:sp>
         <p:sp>
           <p:nvSpPr>
-            <p:cNvPr id="57" name="tx57"/>
-            <p:cNvSpPr/>
-            <p:nvPr/>
-          </p:nvSpPr>
-          <p:spPr>
-            <a:xfrm>
-              <a:off x="6787346" y="2503994"/>
+            <p:cNvPr id="58" name="tx58"/>
+            <p:cNvSpPr/>
+            <p:nvPr/>
+          </p:nvSpPr>
+          <p:spPr>
+            <a:xfrm>
+              <a:off x="6108727" y="2870168"/>
               <a:ext cx="2192170" cy="154136"/>
             </a:xfrm>
             <a:prstGeom prst="rect">
@@ -4488,14 +4528,14 @@
         </p:sp>
         <p:sp>
           <p:nvSpPr>
-            <p:cNvPr id="58" name="rc58"/>
-            <p:cNvSpPr/>
-            <p:nvPr/>
-          </p:nvSpPr>
-          <p:spPr>
-            <a:xfrm>
-              <a:off x="6787346" y="2758632"/>
-              <a:ext cx="226228" cy="219456"/>
+            <p:cNvPr id="59" name="rc59"/>
+            <p:cNvSpPr/>
+            <p:nvPr/>
+          </p:nvSpPr>
+          <p:spPr>
+            <a:xfrm>
+              <a:off x="6108727" y="3124806"/>
+              <a:ext cx="226228" cy="219455"/>
             </a:xfrm>
             <a:prstGeom prst="rect">
               <a:avLst/>
@@ -4514,13 +4554,13 @@
         </p:sp>
         <p:sp>
           <p:nvSpPr>
-            <p:cNvPr id="59" name="pt59"/>
-            <p:cNvSpPr/>
-            <p:nvPr/>
-          </p:nvSpPr>
-          <p:spPr>
-            <a:xfrm>
-              <a:off x="6843819" y="2811717"/>
+            <p:cNvPr id="60" name="pt60"/>
+            <p:cNvSpPr/>
+            <p:nvPr/>
+          </p:nvSpPr>
+          <p:spPr>
+            <a:xfrm>
+              <a:off x="6165199" y="3177891"/>
               <a:ext cx="113284" cy="113284"/>
             </a:xfrm>
             <a:prstGeom prst="ellipse">
@@ -4549,14 +4589,14 @@
         </p:sp>
         <p:sp>
           <p:nvSpPr>
-            <p:cNvPr id="60" name="rc60"/>
-            <p:cNvSpPr/>
-            <p:nvPr/>
-          </p:nvSpPr>
-          <p:spPr>
-            <a:xfrm>
-              <a:off x="6787346" y="2978088"/>
-              <a:ext cx="226228" cy="219456"/>
+            <p:cNvPr id="61" name="rc61"/>
+            <p:cNvSpPr/>
+            <p:nvPr/>
+          </p:nvSpPr>
+          <p:spPr>
+            <a:xfrm>
+              <a:off x="6108727" y="3344262"/>
+              <a:ext cx="226228" cy="219455"/>
             </a:xfrm>
             <a:prstGeom prst="rect">
               <a:avLst/>
@@ -4575,13 +4615,13 @@
         </p:sp>
         <p:sp>
           <p:nvSpPr>
-            <p:cNvPr id="61" name="pt61"/>
-            <p:cNvSpPr/>
-            <p:nvPr/>
-          </p:nvSpPr>
-          <p:spPr>
-            <a:xfrm>
-              <a:off x="6822966" y="3010321"/>
+            <p:cNvPr id="62" name="pt62"/>
+            <p:cNvSpPr/>
+            <p:nvPr/>
+          </p:nvSpPr>
+          <p:spPr>
+            <a:xfrm>
+              <a:off x="6144346" y="3376495"/>
               <a:ext cx="154989" cy="154989"/>
             </a:xfrm>
             <a:prstGeom prst="ellipse">
@@ -4610,13 +4650,13 @@
         </p:sp>
         <p:sp>
           <p:nvSpPr>
-            <p:cNvPr id="62" name="rc62"/>
-            <p:cNvSpPr/>
-            <p:nvPr/>
-          </p:nvSpPr>
-          <p:spPr>
-            <a:xfrm>
-              <a:off x="6787346" y="3197544"/>
+            <p:cNvPr id="63" name="rc63"/>
+            <p:cNvSpPr/>
+            <p:nvPr/>
+          </p:nvSpPr>
+          <p:spPr>
+            <a:xfrm>
+              <a:off x="6108727" y="3563718"/>
               <a:ext cx="226228" cy="226228"/>
             </a:xfrm>
             <a:prstGeom prst="rect">
@@ -4636,13 +4676,13 @@
         </p:sp>
         <p:sp>
           <p:nvSpPr>
-            <p:cNvPr id="63" name="pt63"/>
-            <p:cNvSpPr/>
-            <p:nvPr/>
-          </p:nvSpPr>
-          <p:spPr>
-            <a:xfrm>
-              <a:off x="6809989" y="3220186"/>
+            <p:cNvPr id="64" name="pt64"/>
+            <p:cNvSpPr/>
+            <p:nvPr/>
+          </p:nvSpPr>
+          <p:spPr>
+            <a:xfrm>
+              <a:off x="6131369" y="3586360"/>
               <a:ext cx="180944" cy="180944"/>
             </a:xfrm>
             <a:prstGeom prst="ellipse">
@@ -4671,13 +4711,13 @@
         </p:sp>
         <p:sp>
           <p:nvSpPr>
-            <p:cNvPr id="64" name="tx64"/>
-            <p:cNvSpPr/>
-            <p:nvPr/>
-          </p:nvSpPr>
-          <p:spPr>
-            <a:xfrm>
-              <a:off x="7095817" y="2820861"/>
+            <p:cNvPr id="65" name="tx65"/>
+            <p:cNvSpPr/>
+            <p:nvPr/>
+          </p:nvSpPr>
+          <p:spPr>
+            <a:xfrm>
+              <a:off x="6417197" y="3187035"/>
               <a:ext cx="183609" cy="94868"/>
             </a:xfrm>
             <a:prstGeom prst="rect">
@@ -4717,13 +4757,13 @@
         </p:sp>
         <p:sp>
           <p:nvSpPr>
-            <p:cNvPr id="65" name="tx65"/>
-            <p:cNvSpPr/>
-            <p:nvPr/>
-          </p:nvSpPr>
-          <p:spPr>
-            <a:xfrm>
-              <a:off x="7095817" y="3039995"/>
+            <p:cNvPr id="66" name="tx66"/>
+            <p:cNvSpPr/>
+            <p:nvPr/>
+          </p:nvSpPr>
+          <p:spPr>
+            <a:xfrm>
+              <a:off x="6417197" y="3406169"/>
               <a:ext cx="183609" cy="95190"/>
             </a:xfrm>
             <a:prstGeom prst="rect">
@@ -4763,13 +4803,13 @@
         </p:sp>
         <p:sp>
           <p:nvSpPr>
-            <p:cNvPr id="66" name="tx66"/>
-            <p:cNvSpPr/>
-            <p:nvPr/>
-          </p:nvSpPr>
-          <p:spPr>
-            <a:xfrm>
-              <a:off x="7095817" y="3263030"/>
+            <p:cNvPr id="67" name="tx67"/>
+            <p:cNvSpPr/>
+            <p:nvPr/>
+          </p:nvSpPr>
+          <p:spPr>
+            <a:xfrm>
+              <a:off x="6417197" y="3629204"/>
               <a:ext cx="183609" cy="94996"/>
             </a:xfrm>
             <a:prstGeom prst="rect">
@@ -4809,13 +4849,13 @@
         </p:sp>
         <p:sp>
           <p:nvSpPr>
-            <p:cNvPr id="67" name="rc67"/>
-            <p:cNvSpPr/>
-            <p:nvPr/>
-          </p:nvSpPr>
-          <p:spPr>
-            <a:xfrm>
-              <a:off x="6705105" y="3670497"/>
+            <p:cNvPr id="68" name="rc68"/>
+            <p:cNvSpPr/>
+            <p:nvPr/>
+          </p:nvSpPr>
+          <p:spPr>
+            <a:xfrm>
+              <a:off x="6026485" y="4036671"/>
               <a:ext cx="1428017" cy="840982"/>
             </a:xfrm>
             <a:prstGeom prst="rect">
@@ -4835,13 +4875,13 @@
         </p:sp>
         <p:sp>
           <p:nvSpPr>
-            <p:cNvPr id="68" name="tx68"/>
-            <p:cNvSpPr/>
-            <p:nvPr/>
-          </p:nvSpPr>
-          <p:spPr>
-            <a:xfrm>
-              <a:off x="6787346" y="3764468"/>
+            <p:cNvPr id="69" name="tx69"/>
+            <p:cNvSpPr/>
+            <p:nvPr/>
+          </p:nvSpPr>
+          <p:spPr>
+            <a:xfrm>
+              <a:off x="6108727" y="4130642"/>
               <a:ext cx="504570" cy="125356"/>
             </a:xfrm>
             <a:prstGeom prst="rect">
@@ -4881,14 +4921,14 @@
         </p:sp>
         <p:sp>
           <p:nvSpPr>
-            <p:cNvPr id="69" name="rc69"/>
-            <p:cNvSpPr/>
-            <p:nvPr/>
-          </p:nvSpPr>
-          <p:spPr>
-            <a:xfrm>
-              <a:off x="6787346" y="3990326"/>
-              <a:ext cx="219455" cy="219455"/>
+            <p:cNvPr id="70" name="rc70"/>
+            <p:cNvSpPr/>
+            <p:nvPr/>
+          </p:nvSpPr>
+          <p:spPr>
+            <a:xfrm>
+              <a:off x="6108727" y="4356500"/>
+              <a:ext cx="219455" cy="219456"/>
             </a:xfrm>
             <a:prstGeom prst="rect">
               <a:avLst/>
@@ -4907,13 +4947,13 @@
         </p:sp>
         <p:sp>
           <p:nvSpPr>
-            <p:cNvPr id="70" name="pt70"/>
-            <p:cNvSpPr/>
-            <p:nvPr/>
-          </p:nvSpPr>
-          <p:spPr>
-            <a:xfrm>
-              <a:off x="6867734" y="4070714"/>
+            <p:cNvPr id="71" name="pt71"/>
+            <p:cNvSpPr/>
+            <p:nvPr/>
+          </p:nvSpPr>
+          <p:spPr>
+            <a:xfrm>
+              <a:off x="6189115" y="4436888"/>
               <a:ext cx="58679" cy="58679"/>
             </a:xfrm>
             <a:prstGeom prst="ellipse">
@@ -4942,13 +4982,13 @@
         </p:sp>
         <p:sp>
           <p:nvSpPr>
-            <p:cNvPr id="71" name="tx71"/>
-            <p:cNvSpPr/>
-            <p:nvPr/>
-          </p:nvSpPr>
-          <p:spPr>
-            <a:xfrm>
-              <a:off x="6864920" y="4077554"/>
+            <p:cNvPr id="72" name="tx72"/>
+            <p:cNvSpPr/>
+            <p:nvPr/>
+          </p:nvSpPr>
+          <p:spPr>
+            <a:xfrm>
+              <a:off x="6186300" y="4443728"/>
               <a:ext cx="64309" cy="63970"/>
             </a:xfrm>
             <a:prstGeom prst="rect">
@@ -4988,14 +5028,14 @@
         </p:sp>
         <p:sp>
           <p:nvSpPr>
-            <p:cNvPr id="72" name="rc72"/>
-            <p:cNvSpPr/>
-            <p:nvPr/>
-          </p:nvSpPr>
-          <p:spPr>
-            <a:xfrm>
-              <a:off x="6787346" y="4209782"/>
-              <a:ext cx="219455" cy="219455"/>
+            <p:cNvPr id="73" name="rc73"/>
+            <p:cNvSpPr/>
+            <p:nvPr/>
+          </p:nvSpPr>
+          <p:spPr>
+            <a:xfrm>
+              <a:off x="6108727" y="4575956"/>
+              <a:ext cx="219455" cy="219456"/>
             </a:xfrm>
             <a:prstGeom prst="rect">
               <a:avLst/>
@@ -5014,13 +5054,13 @@
         </p:sp>
         <p:sp>
           <p:nvSpPr>
-            <p:cNvPr id="73" name="pt73"/>
-            <p:cNvSpPr/>
-            <p:nvPr/>
-          </p:nvSpPr>
-          <p:spPr>
-            <a:xfrm>
-              <a:off x="6867734" y="4290170"/>
+            <p:cNvPr id="74" name="pt74"/>
+            <p:cNvSpPr/>
+            <p:nvPr/>
+          </p:nvSpPr>
+          <p:spPr>
+            <a:xfrm>
+              <a:off x="6189115" y="4656344"/>
               <a:ext cx="58679" cy="58679"/>
             </a:xfrm>
             <a:prstGeom prst="ellipse">
@@ -5049,13 +5089,13 @@
         </p:sp>
         <p:sp>
           <p:nvSpPr>
-            <p:cNvPr id="74" name="tx74"/>
-            <p:cNvSpPr/>
-            <p:nvPr/>
-          </p:nvSpPr>
-          <p:spPr>
-            <a:xfrm>
-              <a:off x="6864920" y="4297010"/>
+            <p:cNvPr id="75" name="tx75"/>
+            <p:cNvSpPr/>
+            <p:nvPr/>
+          </p:nvSpPr>
+          <p:spPr>
+            <a:xfrm>
+              <a:off x="6186300" y="4663184"/>
               <a:ext cx="64309" cy="63970"/>
             </a:xfrm>
             <a:prstGeom prst="rect">
@@ -5095,13 +5135,13 @@
         </p:sp>
         <p:sp>
           <p:nvSpPr>
-            <p:cNvPr id="75" name="tx75"/>
-            <p:cNvSpPr/>
-            <p:nvPr/>
-          </p:nvSpPr>
-          <p:spPr>
-            <a:xfrm>
-              <a:off x="7089044" y="4049718"/>
+            <p:cNvPr id="76" name="tx76"/>
+            <p:cNvSpPr/>
+            <p:nvPr/>
+          </p:nvSpPr>
+          <p:spPr>
+            <a:xfrm>
+              <a:off x="6410424" y="4415892"/>
               <a:ext cx="961836" cy="97705"/>
             </a:xfrm>
             <a:prstGeom prst="rect">
@@ -5141,13 +5181,13 @@
         </p:sp>
         <p:sp>
           <p:nvSpPr>
-            <p:cNvPr id="76" name="tx76"/>
-            <p:cNvSpPr/>
-            <p:nvPr/>
-          </p:nvSpPr>
-          <p:spPr>
-            <a:xfrm>
-              <a:off x="7089044" y="4243957"/>
+            <p:cNvPr id="77" name="tx77"/>
+            <p:cNvSpPr/>
+            <p:nvPr/>
+          </p:nvSpPr>
+          <p:spPr>
+            <a:xfrm>
+              <a:off x="6410424" y="4610131"/>
               <a:ext cx="521290" cy="122922"/>
             </a:xfrm>
             <a:prstGeom prst="rect">
@@ -5187,13 +5227,13 @@
         </p:sp>
         <p:sp>
           <p:nvSpPr>
-            <p:cNvPr id="77" name="tx77"/>
-            <p:cNvSpPr/>
-            <p:nvPr/>
-          </p:nvSpPr>
-          <p:spPr>
-            <a:xfrm>
-              <a:off x="536334" y="293566"/>
+            <p:cNvPr id="78" name="tx78"/>
+            <p:cNvSpPr/>
+            <p:nvPr/>
+          </p:nvSpPr>
+          <p:spPr>
+            <a:xfrm>
+              <a:off x="1148528" y="1963355"/>
               <a:ext cx="11499521" cy="156635"/>
             </a:xfrm>
             <a:prstGeom prst="rect">
@@ -5233,13 +5273,13 @@
         </p:sp>
         <p:sp>
           <p:nvSpPr>
-            <p:cNvPr id="78" name="tx78"/>
-            <p:cNvSpPr/>
-            <p:nvPr/>
-          </p:nvSpPr>
-          <p:spPr>
-            <a:xfrm>
-              <a:off x="536334" y="40656"/>
+            <p:cNvPr id="79" name="tx79"/>
+            <p:cNvSpPr/>
+            <p:nvPr/>
+          </p:nvSpPr>
+          <p:spPr>
+            <a:xfrm>
+              <a:off x="1148528" y="1710445"/>
               <a:ext cx="5177296" cy="169552"/>
             </a:xfrm>
             <a:prstGeom prst="rect">

</xml_diff>